<commit_message>
fix(pptx): top-right PiP placeholder, layout validation hard gate
- PiP camera zone moved from bottom-right to top-right
- PiP rendered as semi-transparent placeholder with "Nine" label and dashed border
- Content uses full slide width freely (PiP is overlay only)
- Added validate_slide_layout() that checks for text-text overlaps
- Validation runs after every deck render — warns on issues
- Dynamic vertical placement for drill blocks (placed below content, not at fixed Y)
- Dialogue turn elements (pill + Thai + English) excluded from overlap detection
- Both L001 and L002 pass validation with 0 issues

Co-Authored-By: Claude Opus 4.6 (1M context) <noreply@anthropic.com>

Former-commit-id: 6e60c88e8d3870ad44c4c07318d0044ede32ea6a
Former-commit-id: fb2f1cc287bf8379c0165b292e0ebfe0bb851761
Former-commit-id: f0b49ac3ee76abd51f2035001c7f255fd3439d13
</commit_message>
<xml_diff>
--- a/course/modules/M01/L001/M01-L001-deck.pptx
+++ b/course/modules/M01/L001/M01-L001-deck.pptx
@@ -3107,23 +3107,28 @@
       <p:grpSpPr/>
       <p:sp>
         <p:nvSpPr>
-          <p:cNvPr id="2" name="Rectangle 1"/>
+          <p:cNvPr id="2" name="__pip_placeholder__"/>
           <p:cNvSpPr/>
           <p:nvPr/>
         </p:nvSpPr>
         <p:spPr>
           <a:xfrm>
-            <a:off x="8351215" y="3977640"/>
+            <a:off x="8351215" y="0"/>
             <a:ext cx="3840480" cy="2880360"/>
           </a:xfrm>
           <a:prstGeom prst="rect">
             <a:avLst/>
           </a:prstGeom>
           <a:solidFill>
-            <a:srgbClr val="DBE7EC"/>
+            <a:srgbClr val="DBE7EC">
+              <a:alpha val="30000"/>
+            </a:srgbClr>
           </a:solidFill>
-          <a:ln>
-            <a:noFill/>
+          <a:ln w="19050">
+            <a:solidFill>
+              <a:srgbClr val="355C7D"/>
+            </a:solidFill>
+            <a:prstDash val="sysDash"/>
           </a:ln>
         </p:spPr>
         <p:style>
@@ -3141,10 +3146,19 @@
           </a:fontRef>
         </p:style>
         <p:txBody>
-          <a:bodyPr rtlCol="0" anchor="ctr"/>
+          <a:bodyPr rtlCol="0" anchor="ctr" wrap="none"/>
           <a:lstStyle/>
           <a:p>
             <a:pPr algn="ctr"/>
+            <a:r>
+              <a:rPr sz="1800" b="1">
+                <a:solidFill>
+                  <a:srgbClr val="355C7D"/>
+                </a:solidFill>
+                <a:latin typeface="Sarabun"/>
+              </a:rPr>
+              <a:t>Nine</a:t>
+            </a:r>
           </a:p>
         </p:txBody>
       </p:sp>
@@ -3611,23 +3625,28 @@
       <p:grpSpPr/>
       <p:sp>
         <p:nvSpPr>
-          <p:cNvPr id="2" name="Rectangle 1"/>
+          <p:cNvPr id="2" name="__pip_placeholder__"/>
           <p:cNvSpPr/>
           <p:nvPr/>
         </p:nvSpPr>
         <p:spPr>
           <a:xfrm>
-            <a:off x="8351215" y="3977640"/>
+            <a:off x="8351215" y="0"/>
             <a:ext cx="3840480" cy="2880360"/>
           </a:xfrm>
           <a:prstGeom prst="rect">
             <a:avLst/>
           </a:prstGeom>
           <a:solidFill>
-            <a:srgbClr val="DBE7EC"/>
+            <a:srgbClr val="DBE7EC">
+              <a:alpha val="30000"/>
+            </a:srgbClr>
           </a:solidFill>
-          <a:ln>
-            <a:noFill/>
+          <a:ln w="19050">
+            <a:solidFill>
+              <a:srgbClr val="355C7D"/>
+            </a:solidFill>
+            <a:prstDash val="sysDash"/>
           </a:ln>
         </p:spPr>
         <p:style>
@@ -3645,10 +3664,19 @@
           </a:fontRef>
         </p:style>
         <p:txBody>
-          <a:bodyPr rtlCol="0" anchor="ctr"/>
+          <a:bodyPr rtlCol="0" anchor="ctr" wrap="none"/>
           <a:lstStyle/>
           <a:p>
             <a:pPr algn="ctr"/>
+            <a:r>
+              <a:rPr sz="1800" b="1">
+                <a:solidFill>
+                  <a:srgbClr val="355C7D"/>
+                </a:solidFill>
+                <a:latin typeface="Sarabun"/>
+              </a:rPr>
+              <a:t>Nine</a:t>
+            </a:r>
           </a:p>
         </p:txBody>
       </p:sp>
@@ -4041,23 +4069,28 @@
       <p:grpSpPr/>
       <p:sp>
         <p:nvSpPr>
-          <p:cNvPr id="2" name="Rectangle 1"/>
+          <p:cNvPr id="2" name="__pip_placeholder__"/>
           <p:cNvSpPr/>
           <p:nvPr/>
         </p:nvSpPr>
         <p:spPr>
           <a:xfrm>
-            <a:off x="8351215" y="3977640"/>
+            <a:off x="8351215" y="0"/>
             <a:ext cx="3840480" cy="2880360"/>
           </a:xfrm>
           <a:prstGeom prst="rect">
             <a:avLst/>
           </a:prstGeom>
           <a:solidFill>
-            <a:srgbClr val="DBE7EC"/>
+            <a:srgbClr val="DBE7EC">
+              <a:alpha val="30000"/>
+            </a:srgbClr>
           </a:solidFill>
-          <a:ln>
-            <a:noFill/>
+          <a:ln w="19050">
+            <a:solidFill>
+              <a:srgbClr val="355C7D"/>
+            </a:solidFill>
+            <a:prstDash val="sysDash"/>
           </a:ln>
         </p:spPr>
         <p:style>
@@ -4075,10 +4108,19 @@
           </a:fontRef>
         </p:style>
         <p:txBody>
-          <a:bodyPr rtlCol="0" anchor="ctr"/>
+          <a:bodyPr rtlCol="0" anchor="ctr" wrap="none"/>
           <a:lstStyle/>
           <a:p>
             <a:pPr algn="ctr"/>
+            <a:r>
+              <a:rPr sz="1800" b="1">
+                <a:solidFill>
+                  <a:srgbClr val="355C7D"/>
+                </a:solidFill>
+                <a:latin typeface="Sarabun"/>
+              </a:rPr>
+              <a:t>Nine</a:t>
+            </a:r>
           </a:p>
         </p:txBody>
       </p:sp>
@@ -4711,23 +4753,28 @@
       <p:grpSpPr/>
       <p:sp>
         <p:nvSpPr>
-          <p:cNvPr id="2" name="Rectangle 1"/>
+          <p:cNvPr id="2" name="__pip_placeholder__"/>
           <p:cNvSpPr/>
           <p:nvPr/>
         </p:nvSpPr>
         <p:spPr>
           <a:xfrm>
-            <a:off x="8351215" y="3977640"/>
+            <a:off x="8351215" y="0"/>
             <a:ext cx="3840480" cy="2880360"/>
           </a:xfrm>
           <a:prstGeom prst="rect">
             <a:avLst/>
           </a:prstGeom>
           <a:solidFill>
-            <a:srgbClr val="DBE7EC"/>
+            <a:srgbClr val="DBE7EC">
+              <a:alpha val="30000"/>
+            </a:srgbClr>
           </a:solidFill>
-          <a:ln>
-            <a:noFill/>
+          <a:ln w="19050">
+            <a:solidFill>
+              <a:srgbClr val="355C7D"/>
+            </a:solidFill>
+            <a:prstDash val="sysDash"/>
           </a:ln>
         </p:spPr>
         <p:style>
@@ -4745,10 +4792,19 @@
           </a:fontRef>
         </p:style>
         <p:txBody>
-          <a:bodyPr rtlCol="0" anchor="ctr"/>
+          <a:bodyPr rtlCol="0" anchor="ctr" wrap="none"/>
           <a:lstStyle/>
           <a:p>
             <a:pPr algn="ctr"/>
+            <a:r>
+              <a:rPr sz="1800" b="1">
+                <a:solidFill>
+                  <a:srgbClr val="355C7D"/>
+                </a:solidFill>
+                <a:latin typeface="Sarabun"/>
+              </a:rPr>
+              <a:t>Nine</a:t>
+            </a:r>
           </a:p>
         </p:txBody>
       </p:sp>
@@ -5402,7 +5458,7 @@
         </p:nvSpPr>
         <p:spPr>
           <a:xfrm>
-            <a:off x="731520" y="4434840"/>
+            <a:off x="731520" y="6775704"/>
             <a:ext cx="10058400" cy="1636776"/>
           </a:xfrm>
           <a:prstGeom prst="roundRect">
@@ -5449,7 +5505,7 @@
         </p:nvSpPr>
         <p:spPr>
           <a:xfrm>
-            <a:off x="932688" y="4581144"/>
+            <a:off x="932688" y="6922008"/>
             <a:ext cx="9692640" cy="228600"/>
           </a:xfrm>
           <a:prstGeom prst="rect">
@@ -5486,7 +5542,7 @@
         </p:nvSpPr>
         <p:spPr>
           <a:xfrm>
-            <a:off x="932688" y="4965192"/>
+            <a:off x="932688" y="7306056"/>
             <a:ext cx="82296" cy="82296"/>
           </a:xfrm>
           <a:prstGeom prst="ellipse">
@@ -5529,7 +5585,7 @@
         </p:nvSpPr>
         <p:spPr>
           <a:xfrm>
-            <a:off x="1078992" y="4873752"/>
+            <a:off x="1078992" y="7214616"/>
             <a:ext cx="9555480" cy="274320"/>
           </a:xfrm>
           <a:prstGeom prst="rect">
@@ -5665,7 +5721,7 @@
         </p:nvSpPr>
         <p:spPr>
           <a:xfrm>
-            <a:off x="932688" y="5276088"/>
+            <a:off x="932688" y="7616952"/>
             <a:ext cx="82296" cy="82296"/>
           </a:xfrm>
           <a:prstGeom prst="ellipse">
@@ -5708,7 +5764,7 @@
         </p:nvSpPr>
         <p:spPr>
           <a:xfrm>
-            <a:off x="1078992" y="5184648"/>
+            <a:off x="1078992" y="7525512"/>
             <a:ext cx="9555480" cy="274320"/>
           </a:xfrm>
           <a:prstGeom prst="rect">
@@ -5745,7 +5801,7 @@
         </p:nvSpPr>
         <p:spPr>
           <a:xfrm>
-            <a:off x="932688" y="5586984"/>
+            <a:off x="932688" y="7927848"/>
             <a:ext cx="82296" cy="82296"/>
           </a:xfrm>
           <a:prstGeom prst="ellipse">
@@ -5788,7 +5844,7 @@
         </p:nvSpPr>
         <p:spPr>
           <a:xfrm>
-            <a:off x="1078992" y="5495544"/>
+            <a:off x="1078992" y="7836408"/>
             <a:ext cx="9555480" cy="274320"/>
           </a:xfrm>
           <a:prstGeom prst="rect">
@@ -5944,23 +6000,28 @@
       <p:grpSpPr/>
       <p:sp>
         <p:nvSpPr>
-          <p:cNvPr id="2" name="Rectangle 1"/>
+          <p:cNvPr id="2" name="__pip_placeholder__"/>
           <p:cNvSpPr/>
           <p:nvPr/>
         </p:nvSpPr>
         <p:spPr>
           <a:xfrm>
-            <a:off x="8351215" y="3977640"/>
+            <a:off x="8351215" y="0"/>
             <a:ext cx="3840480" cy="2880360"/>
           </a:xfrm>
           <a:prstGeom prst="rect">
             <a:avLst/>
           </a:prstGeom>
           <a:solidFill>
-            <a:srgbClr val="DBE7EC"/>
+            <a:srgbClr val="DBE7EC">
+              <a:alpha val="30000"/>
+            </a:srgbClr>
           </a:solidFill>
-          <a:ln>
-            <a:noFill/>
+          <a:ln w="19050">
+            <a:solidFill>
+              <a:srgbClr val="355C7D"/>
+            </a:solidFill>
+            <a:prstDash val="sysDash"/>
           </a:ln>
         </p:spPr>
         <p:style>
@@ -5978,10 +6039,19 @@
           </a:fontRef>
         </p:style>
         <p:txBody>
-          <a:bodyPr rtlCol="0" anchor="ctr"/>
+          <a:bodyPr rtlCol="0" anchor="ctr" wrap="none"/>
           <a:lstStyle/>
           <a:p>
             <a:pPr algn="ctr"/>
+            <a:r>
+              <a:rPr sz="1800" b="1">
+                <a:solidFill>
+                  <a:srgbClr val="355C7D"/>
+                </a:solidFill>
+                <a:latin typeface="Sarabun"/>
+              </a:rPr>
+              <a:t>Nine</a:t>
+            </a:r>
           </a:p>
         </p:txBody>
       </p:sp>
@@ -6635,7 +6705,7 @@
         </p:nvSpPr>
         <p:spPr>
           <a:xfrm>
-            <a:off x="731520" y="4434840"/>
+            <a:off x="731520" y="6775704"/>
             <a:ext cx="10058400" cy="1636776"/>
           </a:xfrm>
           <a:prstGeom prst="roundRect">
@@ -6682,7 +6752,7 @@
         </p:nvSpPr>
         <p:spPr>
           <a:xfrm>
-            <a:off x="932688" y="4581144"/>
+            <a:off x="932688" y="6922008"/>
             <a:ext cx="9692640" cy="228600"/>
           </a:xfrm>
           <a:prstGeom prst="rect">
@@ -6719,7 +6789,7 @@
         </p:nvSpPr>
         <p:spPr>
           <a:xfrm>
-            <a:off x="932688" y="4965192"/>
+            <a:off x="932688" y="7306056"/>
             <a:ext cx="82296" cy="82296"/>
           </a:xfrm>
           <a:prstGeom prst="ellipse">
@@ -6762,7 +6832,7 @@
         </p:nvSpPr>
         <p:spPr>
           <a:xfrm>
-            <a:off x="1078992" y="4873752"/>
+            <a:off x="1078992" y="7214616"/>
             <a:ext cx="9555480" cy="274320"/>
           </a:xfrm>
           <a:prstGeom prst="rect">
@@ -6865,7 +6935,7 @@
         </p:nvSpPr>
         <p:spPr>
           <a:xfrm>
-            <a:off x="932688" y="5276088"/>
+            <a:off x="932688" y="7616952"/>
             <a:ext cx="82296" cy="82296"/>
           </a:xfrm>
           <a:prstGeom prst="ellipse">
@@ -6908,7 +6978,7 @@
         </p:nvSpPr>
         <p:spPr>
           <a:xfrm>
-            <a:off x="1078992" y="5184648"/>
+            <a:off x="1078992" y="7525512"/>
             <a:ext cx="9555480" cy="274320"/>
           </a:xfrm>
           <a:prstGeom prst="rect">
@@ -7000,7 +7070,7 @@
         </p:nvSpPr>
         <p:spPr>
           <a:xfrm>
-            <a:off x="932688" y="5586984"/>
+            <a:off x="932688" y="7927848"/>
             <a:ext cx="82296" cy="82296"/>
           </a:xfrm>
           <a:prstGeom prst="ellipse">
@@ -7043,7 +7113,7 @@
         </p:nvSpPr>
         <p:spPr>
           <a:xfrm>
-            <a:off x="1078992" y="5495544"/>
+            <a:off x="1078992" y="7836408"/>
             <a:ext cx="9555480" cy="274320"/>
           </a:xfrm>
           <a:prstGeom prst="rect">
@@ -7298,23 +7368,28 @@
       <p:grpSpPr/>
       <p:sp>
         <p:nvSpPr>
-          <p:cNvPr id="2" name="Rectangle 1"/>
+          <p:cNvPr id="2" name="__pip_placeholder__"/>
           <p:cNvSpPr/>
           <p:nvPr/>
         </p:nvSpPr>
         <p:spPr>
           <a:xfrm>
-            <a:off x="8351215" y="3977640"/>
+            <a:off x="8351215" y="0"/>
             <a:ext cx="3840480" cy="2880360"/>
           </a:xfrm>
           <a:prstGeom prst="rect">
             <a:avLst/>
           </a:prstGeom>
           <a:solidFill>
-            <a:srgbClr val="DBE7EC"/>
+            <a:srgbClr val="DBE7EC">
+              <a:alpha val="30000"/>
+            </a:srgbClr>
           </a:solidFill>
-          <a:ln>
-            <a:noFill/>
+          <a:ln w="19050">
+            <a:solidFill>
+              <a:srgbClr val="355C7D"/>
+            </a:solidFill>
+            <a:prstDash val="sysDash"/>
           </a:ln>
         </p:spPr>
         <p:style>
@@ -7332,10 +7407,19 @@
           </a:fontRef>
         </p:style>
         <p:txBody>
-          <a:bodyPr rtlCol="0" anchor="ctr"/>
+          <a:bodyPr rtlCol="0" anchor="ctr" wrap="none"/>
           <a:lstStyle/>
           <a:p>
             <a:pPr algn="ctr"/>
+            <a:r>
+              <a:rPr sz="1800" b="1">
+                <a:solidFill>
+                  <a:srgbClr val="355C7D"/>
+                </a:solidFill>
+                <a:latin typeface="Sarabun"/>
+              </a:rPr>
+              <a:t>Nine</a:t>
+            </a:r>
           </a:p>
         </p:txBody>
       </p:sp>
@@ -7989,7 +8073,7 @@
         </p:nvSpPr>
         <p:spPr>
           <a:xfrm>
-            <a:off x="731520" y="4434840"/>
+            <a:off x="731520" y="6775704"/>
             <a:ext cx="10058400" cy="1636776"/>
           </a:xfrm>
           <a:prstGeom prst="roundRect">
@@ -8036,7 +8120,7 @@
         </p:nvSpPr>
         <p:spPr>
           <a:xfrm>
-            <a:off x="932688" y="4581144"/>
+            <a:off x="932688" y="6922008"/>
             <a:ext cx="9692640" cy="228600"/>
           </a:xfrm>
           <a:prstGeom prst="rect">
@@ -8073,7 +8157,7 @@
         </p:nvSpPr>
         <p:spPr>
           <a:xfrm>
-            <a:off x="932688" y="4965192"/>
+            <a:off x="932688" y="7306056"/>
             <a:ext cx="82296" cy="82296"/>
           </a:xfrm>
           <a:prstGeom prst="ellipse">
@@ -8116,7 +8200,7 @@
         </p:nvSpPr>
         <p:spPr>
           <a:xfrm>
-            <a:off x="1078992" y="4873752"/>
+            <a:off x="1078992" y="7214616"/>
             <a:ext cx="9555480" cy="274320"/>
           </a:xfrm>
           <a:prstGeom prst="rect">
@@ -8252,7 +8336,7 @@
         </p:nvSpPr>
         <p:spPr>
           <a:xfrm>
-            <a:off x="932688" y="5276088"/>
+            <a:off x="932688" y="7616952"/>
             <a:ext cx="82296" cy="82296"/>
           </a:xfrm>
           <a:prstGeom prst="ellipse">
@@ -8295,7 +8379,7 @@
         </p:nvSpPr>
         <p:spPr>
           <a:xfrm>
-            <a:off x="1078992" y="5184648"/>
+            <a:off x="1078992" y="7525512"/>
             <a:ext cx="9555480" cy="274320"/>
           </a:xfrm>
           <a:prstGeom prst="rect">
@@ -8398,7 +8482,7 @@
         </p:nvSpPr>
         <p:spPr>
           <a:xfrm>
-            <a:off x="932688" y="5586984"/>
+            <a:off x="932688" y="7927848"/>
             <a:ext cx="82296" cy="82296"/>
           </a:xfrm>
           <a:prstGeom prst="ellipse">
@@ -8441,7 +8525,7 @@
         </p:nvSpPr>
         <p:spPr>
           <a:xfrm>
-            <a:off x="1078992" y="5495544"/>
+            <a:off x="1078992" y="7836408"/>
             <a:ext cx="9555480" cy="274320"/>
           </a:xfrm>
           <a:prstGeom prst="rect">
@@ -8630,23 +8714,28 @@
       <p:grpSpPr/>
       <p:sp>
         <p:nvSpPr>
-          <p:cNvPr id="2" name="Rectangle 1"/>
+          <p:cNvPr id="2" name="__pip_placeholder__"/>
           <p:cNvSpPr/>
           <p:nvPr/>
         </p:nvSpPr>
         <p:spPr>
           <a:xfrm>
-            <a:off x="8351215" y="3977640"/>
+            <a:off x="8351215" y="0"/>
             <a:ext cx="3840480" cy="2880360"/>
           </a:xfrm>
           <a:prstGeom prst="rect">
             <a:avLst/>
           </a:prstGeom>
           <a:solidFill>
-            <a:srgbClr val="DBE7EC"/>
+            <a:srgbClr val="DBE7EC">
+              <a:alpha val="30000"/>
+            </a:srgbClr>
           </a:solidFill>
-          <a:ln>
-            <a:noFill/>
+          <a:ln w="19050">
+            <a:solidFill>
+              <a:srgbClr val="355C7D"/>
+            </a:solidFill>
+            <a:prstDash val="sysDash"/>
           </a:ln>
         </p:spPr>
         <p:style>
@@ -8664,10 +8753,19 @@
           </a:fontRef>
         </p:style>
         <p:txBody>
-          <a:bodyPr rtlCol="0" anchor="ctr"/>
+          <a:bodyPr rtlCol="0" anchor="ctr" wrap="none"/>
           <a:lstStyle/>
           <a:p>
             <a:pPr algn="ctr"/>
+            <a:r>
+              <a:rPr sz="1800" b="1">
+                <a:solidFill>
+                  <a:srgbClr val="355C7D"/>
+                </a:solidFill>
+                <a:latin typeface="Sarabun"/>
+              </a:rPr>
+              <a:t>Nine</a:t>
+            </a:r>
           </a:p>
         </p:txBody>
       </p:sp>
@@ -9321,7 +9419,7 @@
         </p:nvSpPr>
         <p:spPr>
           <a:xfrm>
-            <a:off x="731520" y="4434840"/>
+            <a:off x="731520" y="6775704"/>
             <a:ext cx="10058400" cy="1636776"/>
           </a:xfrm>
           <a:prstGeom prst="roundRect">
@@ -9368,7 +9466,7 @@
         </p:nvSpPr>
         <p:spPr>
           <a:xfrm>
-            <a:off x="932688" y="4581144"/>
+            <a:off x="932688" y="6922008"/>
             <a:ext cx="9692640" cy="228600"/>
           </a:xfrm>
           <a:prstGeom prst="rect">
@@ -9405,7 +9503,7 @@
         </p:nvSpPr>
         <p:spPr>
           <a:xfrm>
-            <a:off x="932688" y="4965192"/>
+            <a:off x="932688" y="7306056"/>
             <a:ext cx="82296" cy="82296"/>
           </a:xfrm>
           <a:prstGeom prst="ellipse">
@@ -9448,7 +9546,7 @@
         </p:nvSpPr>
         <p:spPr>
           <a:xfrm>
-            <a:off x="1078992" y="4873752"/>
+            <a:off x="1078992" y="7214616"/>
             <a:ext cx="9555480" cy="274320"/>
           </a:xfrm>
           <a:prstGeom prst="rect">
@@ -9551,7 +9649,7 @@
         </p:nvSpPr>
         <p:spPr>
           <a:xfrm>
-            <a:off x="932688" y="5276088"/>
+            <a:off x="932688" y="7616952"/>
             <a:ext cx="82296" cy="82296"/>
           </a:xfrm>
           <a:prstGeom prst="ellipse">
@@ -9594,7 +9692,7 @@
         </p:nvSpPr>
         <p:spPr>
           <a:xfrm>
-            <a:off x="1078992" y="5184648"/>
+            <a:off x="1078992" y="7525512"/>
             <a:ext cx="9555480" cy="274320"/>
           </a:xfrm>
           <a:prstGeom prst="rect">
@@ -9741,7 +9839,7 @@
         </p:nvSpPr>
         <p:spPr>
           <a:xfrm>
-            <a:off x="932688" y="5586984"/>
+            <a:off x="932688" y="7927848"/>
             <a:ext cx="82296" cy="82296"/>
           </a:xfrm>
           <a:prstGeom prst="ellipse">
@@ -9784,7 +9882,7 @@
         </p:nvSpPr>
         <p:spPr>
           <a:xfrm>
-            <a:off x="1078992" y="5495544"/>
+            <a:off x="1078992" y="7836408"/>
             <a:ext cx="9555480" cy="274320"/>
           </a:xfrm>
           <a:prstGeom prst="rect">
@@ -10039,23 +10137,28 @@
       <p:grpSpPr/>
       <p:sp>
         <p:nvSpPr>
-          <p:cNvPr id="2" name="Rectangle 1"/>
+          <p:cNvPr id="2" name="__pip_placeholder__"/>
           <p:cNvSpPr/>
           <p:nvPr/>
         </p:nvSpPr>
         <p:spPr>
           <a:xfrm>
-            <a:off x="8351215" y="3977640"/>
+            <a:off x="8351215" y="0"/>
             <a:ext cx="3840480" cy="2880360"/>
           </a:xfrm>
           <a:prstGeom prst="rect">
             <a:avLst/>
           </a:prstGeom>
           <a:solidFill>
-            <a:srgbClr val="DBE7EC"/>
+            <a:srgbClr val="DBE7EC">
+              <a:alpha val="30000"/>
+            </a:srgbClr>
           </a:solidFill>
-          <a:ln>
-            <a:noFill/>
+          <a:ln w="19050">
+            <a:solidFill>
+              <a:srgbClr val="355C7D"/>
+            </a:solidFill>
+            <a:prstDash val="sysDash"/>
           </a:ln>
         </p:spPr>
         <p:style>
@@ -10073,10 +10176,19 @@
           </a:fontRef>
         </p:style>
         <p:txBody>
-          <a:bodyPr rtlCol="0" anchor="ctr"/>
+          <a:bodyPr rtlCol="0" anchor="ctr" wrap="none"/>
           <a:lstStyle/>
           <a:p>
             <a:pPr algn="ctr"/>
+            <a:r>
+              <a:rPr sz="1800" b="1">
+                <a:solidFill>
+                  <a:srgbClr val="355C7D"/>
+                </a:solidFill>
+                <a:latin typeface="Sarabun"/>
+              </a:rPr>
+              <a:t>Nine</a:t>
+            </a:r>
           </a:p>
         </p:txBody>
       </p:sp>
@@ -10730,7 +10842,7 @@
         </p:nvSpPr>
         <p:spPr>
           <a:xfrm>
-            <a:off x="731520" y="4434840"/>
+            <a:off x="731520" y="6775704"/>
             <a:ext cx="10058400" cy="1289304"/>
           </a:xfrm>
           <a:prstGeom prst="roundRect">
@@ -10777,7 +10889,7 @@
         </p:nvSpPr>
         <p:spPr>
           <a:xfrm>
-            <a:off x="932688" y="4581144"/>
+            <a:off x="932688" y="6922008"/>
             <a:ext cx="9692640" cy="228600"/>
           </a:xfrm>
           <a:prstGeom prst="rect">
@@ -10814,7 +10926,7 @@
         </p:nvSpPr>
         <p:spPr>
           <a:xfrm>
-            <a:off x="932688" y="4965192"/>
+            <a:off x="932688" y="7306056"/>
             <a:ext cx="82296" cy="82296"/>
           </a:xfrm>
           <a:prstGeom prst="ellipse">
@@ -10857,7 +10969,7 @@
         </p:nvSpPr>
         <p:spPr>
           <a:xfrm>
-            <a:off x="1078992" y="4873752"/>
+            <a:off x="1078992" y="7214616"/>
             <a:ext cx="9555480" cy="274320"/>
           </a:xfrm>
           <a:prstGeom prst="rect">
@@ -10960,7 +11072,7 @@
         </p:nvSpPr>
         <p:spPr>
           <a:xfrm>
-            <a:off x="932688" y="5276088"/>
+            <a:off x="932688" y="7616952"/>
             <a:ext cx="82296" cy="82296"/>
           </a:xfrm>
           <a:prstGeom prst="ellipse">
@@ -11003,7 +11115,7 @@
         </p:nvSpPr>
         <p:spPr>
           <a:xfrm>
-            <a:off x="1078992" y="5184648"/>
+            <a:off x="1078992" y="7525512"/>
             <a:ext cx="9555480" cy="274320"/>
           </a:xfrm>
           <a:prstGeom prst="rect">
@@ -11126,23 +11238,28 @@
       <p:grpSpPr/>
       <p:sp>
         <p:nvSpPr>
-          <p:cNvPr id="2" name="Rectangle 1"/>
+          <p:cNvPr id="2" name="__pip_placeholder__"/>
           <p:cNvSpPr/>
           <p:nvPr/>
         </p:nvSpPr>
         <p:spPr>
           <a:xfrm>
-            <a:off x="8351215" y="3977640"/>
+            <a:off x="8351215" y="0"/>
             <a:ext cx="3840480" cy="2880360"/>
           </a:xfrm>
           <a:prstGeom prst="rect">
             <a:avLst/>
           </a:prstGeom>
           <a:solidFill>
-            <a:srgbClr val="DBE7EC"/>
+            <a:srgbClr val="DBE7EC">
+              <a:alpha val="30000"/>
+            </a:srgbClr>
           </a:solidFill>
-          <a:ln>
-            <a:noFill/>
+          <a:ln w="19050">
+            <a:solidFill>
+              <a:srgbClr val="355C7D"/>
+            </a:solidFill>
+            <a:prstDash val="sysDash"/>
           </a:ln>
         </p:spPr>
         <p:style>
@@ -11160,10 +11277,19 @@
           </a:fontRef>
         </p:style>
         <p:txBody>
-          <a:bodyPr rtlCol="0" anchor="ctr"/>
+          <a:bodyPr rtlCol="0" anchor="ctr" wrap="none"/>
           <a:lstStyle/>
           <a:p>
             <a:pPr algn="ctr"/>
+            <a:r>
+              <a:rPr sz="1800" b="1">
+                <a:solidFill>
+                  <a:srgbClr val="355C7D"/>
+                </a:solidFill>
+                <a:latin typeface="Sarabun"/>
+              </a:rPr>
+              <a:t>Nine</a:t>
+            </a:r>
           </a:p>
         </p:txBody>
       </p:sp>
@@ -12158,23 +12284,28 @@
       <p:grpSpPr/>
       <p:sp>
         <p:nvSpPr>
-          <p:cNvPr id="2" name="Rectangle 1"/>
+          <p:cNvPr id="2" name="__pip_placeholder__"/>
           <p:cNvSpPr/>
           <p:nvPr/>
         </p:nvSpPr>
         <p:spPr>
           <a:xfrm>
-            <a:off x="8351215" y="3977640"/>
+            <a:off x="8351215" y="0"/>
             <a:ext cx="3840480" cy="2880360"/>
           </a:xfrm>
           <a:prstGeom prst="rect">
             <a:avLst/>
           </a:prstGeom>
           <a:solidFill>
-            <a:srgbClr val="DBE7EC"/>
+            <a:srgbClr val="DBE7EC">
+              <a:alpha val="30000"/>
+            </a:srgbClr>
           </a:solidFill>
-          <a:ln>
-            <a:noFill/>
+          <a:ln w="19050">
+            <a:solidFill>
+              <a:srgbClr val="355C7D"/>
+            </a:solidFill>
+            <a:prstDash val="sysDash"/>
           </a:ln>
         </p:spPr>
         <p:style>
@@ -12192,10 +12323,19 @@
           </a:fontRef>
         </p:style>
         <p:txBody>
-          <a:bodyPr rtlCol="0" anchor="ctr"/>
+          <a:bodyPr rtlCol="0" anchor="ctr" wrap="none"/>
           <a:lstStyle/>
           <a:p>
             <a:pPr algn="ctr"/>
+            <a:r>
+              <a:rPr sz="1800" b="1">
+                <a:solidFill>
+                  <a:srgbClr val="355C7D"/>
+                </a:solidFill>
+                <a:latin typeface="Sarabun"/>
+              </a:rPr>
+              <a:t>Nine</a:t>
+            </a:r>
           </a:p>
         </p:txBody>
       </p:sp>

</xml_diff>

<commit_message>
fix(pptx): constrain content beside PiP, replace all "learner" with "you"
Layout:
- Added CONTENT_WIDTH_BESIDE_PIP (~8.1") for elements at Y < PiP bottom
- Headers, recap top block, roleplay early turns, opener, closing all use
  constrained width when beside the PiP zone
- Teaching slide columns proportional to constrained width
- Content below PiP still uses full CONTENT_WIDTH (11.0")

Language:
- Replaced all "Learner" with "You" in script-master, spoken scripts,
  visual scripts, and brief for L001 and L002
- Fixed grammar after replacement (meets→meet, does→do, approaches→approach)
- Roleplay scenarios now in 2nd person for 1:1 feel

Co-Authored-By: Claude Opus 4.6 (1M context) <noreply@anthropic.com>

Former-commit-id: 7d0ce4498f41ab8fc56df79ee81fff85eba96adc
Former-commit-id: a094856725f35fc1c31020298a74b677fbb0ba0c
Former-commit-id: 8bb0442e5699ae06e688d6a081209b59da4073fb
</commit_message>
<xml_diff>
--- a/course/modules/M01/L001/M01-L001-deck.pptx
+++ b/course/modules/M01/L001/M01-L001-deck.pptx
@@ -3214,7 +3214,7 @@
         <p:spPr>
           <a:xfrm>
             <a:off x="731520" y="1600200"/>
-            <a:ext cx="10058400" cy="228600"/>
+            <a:ext cx="7436815" cy="228600"/>
           </a:xfrm>
           <a:prstGeom prst="rect">
             <a:avLst/>
@@ -3251,7 +3251,7 @@
         <p:spPr>
           <a:xfrm>
             <a:off x="731520" y="1993392"/>
-            <a:ext cx="10058400" cy="329184"/>
+            <a:ext cx="7436815" cy="329184"/>
           </a:xfrm>
           <a:prstGeom prst="rect">
             <a:avLst/>
@@ -3288,7 +3288,7 @@
         <p:spPr>
           <a:xfrm>
             <a:off x="731520" y="2542032"/>
-            <a:ext cx="10058400" cy="822960"/>
+            <a:ext cx="7436815" cy="822960"/>
           </a:xfrm>
           <a:prstGeom prst="rect">
             <a:avLst/>
@@ -3732,7 +3732,7 @@
         <p:spPr>
           <a:xfrm>
             <a:off x="731520" y="256032"/>
-            <a:ext cx="10058400" cy="256032"/>
+            <a:ext cx="7436815" cy="256032"/>
           </a:xfrm>
           <a:prstGeom prst="rect">
             <a:avLst/>
@@ -3769,7 +3769,7 @@
         <p:spPr>
           <a:xfrm>
             <a:off x="731520" y="530352"/>
-            <a:ext cx="10058400" cy="457200"/>
+            <a:ext cx="7436815" cy="457200"/>
           </a:xfrm>
           <a:prstGeom prst="rect">
             <a:avLst/>
@@ -3806,7 +3806,7 @@
         <p:spPr>
           <a:xfrm>
             <a:off x="731520" y="1600200"/>
-            <a:ext cx="9601200" cy="1289304"/>
+            <a:ext cx="7436815" cy="1289304"/>
           </a:xfrm>
           <a:prstGeom prst="roundRect">
             <a:avLst>
@@ -3853,7 +3853,7 @@
         <p:spPr>
           <a:xfrm>
             <a:off x="932688" y="1746504"/>
-            <a:ext cx="9235440" cy="228600"/>
+            <a:ext cx="7071055" cy="228600"/>
           </a:xfrm>
           <a:prstGeom prst="rect">
             <a:avLst/>
@@ -3933,7 +3933,7 @@
         <p:spPr>
           <a:xfrm>
             <a:off x="1078992" y="2039112"/>
-            <a:ext cx="9098280" cy="274320"/>
+            <a:ext cx="6933895" cy="274320"/>
           </a:xfrm>
           <a:prstGeom prst="rect">
             <a:avLst/>
@@ -3956,7 +3956,7 @@
                 <a:ea typeface="Sarabun"/>
                 <a:cs typeface="Sarabun"/>
               </a:rPr>
-              <a:t>By the end, the learner can open, repair, thank, and close a tiny first-contact exchange politely.</a:t>
+              <a:t>By the end, you can open, repair, thank, and close a tiny first-contact exchange politely.</a:t>
             </a:r>
           </a:p>
         </p:txBody>
@@ -4013,7 +4013,7 @@
         <p:spPr>
           <a:xfrm>
             <a:off x="1078992" y="2350008"/>
-            <a:ext cx="9098280" cy="274320"/>
+            <a:ext cx="6933895" cy="274320"/>
           </a:xfrm>
           <a:prstGeom prst="rect">
             <a:avLst/>
@@ -4176,7 +4176,7 @@
         <p:spPr>
           <a:xfrm>
             <a:off x="731520" y="256032"/>
-            <a:ext cx="10058400" cy="256032"/>
+            <a:ext cx="7436815" cy="256032"/>
           </a:xfrm>
           <a:prstGeom prst="rect">
             <a:avLst/>
@@ -4213,7 +4213,7 @@
         <p:spPr>
           <a:xfrm>
             <a:off x="731520" y="530352"/>
-            <a:ext cx="10058400" cy="457200"/>
+            <a:ext cx="7436815" cy="457200"/>
           </a:xfrm>
           <a:prstGeom prst="rect">
             <a:avLst/>
@@ -4860,7 +4860,7 @@
         <p:spPr>
           <a:xfrm>
             <a:off x="731520" y="256032"/>
-            <a:ext cx="10058400" cy="256032"/>
+            <a:ext cx="7436815" cy="256032"/>
           </a:xfrm>
           <a:prstGeom prst="rect">
             <a:avLst/>
@@ -4897,7 +4897,7 @@
         <p:spPr>
           <a:xfrm>
             <a:off x="731520" y="530352"/>
-            <a:ext cx="10058400" cy="457200"/>
+            <a:ext cx="7436815" cy="457200"/>
           </a:xfrm>
           <a:prstGeom prst="rect">
             <a:avLst/>
@@ -4934,7 +4934,7 @@
         <p:spPr>
           <a:xfrm>
             <a:off x="731520" y="1325880"/>
-            <a:ext cx="5029200" cy="1572768"/>
+            <a:ext cx="4090248" cy="1572768"/>
           </a:xfrm>
           <a:prstGeom prst="roundRect">
             <a:avLst>
@@ -5024,7 +5024,7 @@
         <p:spPr>
           <a:xfrm>
             <a:off x="1078992" y="1435608"/>
-            <a:ext cx="4572000" cy="658368"/>
+            <a:ext cx="3633048" cy="658368"/>
           </a:xfrm>
           <a:prstGeom prst="rect">
             <a:avLst/>
@@ -5072,7 +5072,7 @@
         <p:spPr>
           <a:xfrm>
             <a:off x="1078992" y="2203704"/>
-            <a:ext cx="4572000" cy="274320"/>
+            <a:ext cx="3633048" cy="274320"/>
           </a:xfrm>
           <a:prstGeom prst="rect">
             <a:avLst/>
@@ -5109,7 +5109,7 @@
         <p:spPr>
           <a:xfrm>
             <a:off x="731520" y="3081528"/>
-            <a:ext cx="5029200" cy="1572768"/>
+            <a:ext cx="4090248" cy="1572768"/>
           </a:xfrm>
           <a:prstGeom prst="roundRect">
             <a:avLst>
@@ -5199,7 +5199,7 @@
         <p:spPr>
           <a:xfrm>
             <a:off x="1078992" y="3191256"/>
-            <a:ext cx="4572000" cy="658368"/>
+            <a:ext cx="3633048" cy="658368"/>
           </a:xfrm>
           <a:prstGeom prst="rect">
             <a:avLst/>
@@ -5247,7 +5247,7 @@
         <p:spPr>
           <a:xfrm>
             <a:off x="1078992" y="3959352"/>
-            <a:ext cx="4572000" cy="274320"/>
+            <a:ext cx="3633048" cy="274320"/>
           </a:xfrm>
           <a:prstGeom prst="rect">
             <a:avLst/>
@@ -5284,7 +5284,7 @@
         <p:spPr>
           <a:xfrm>
             <a:off x="731520" y="4837176"/>
-            <a:ext cx="5029200" cy="1572768"/>
+            <a:ext cx="4090248" cy="1572768"/>
           </a:xfrm>
           <a:prstGeom prst="roundRect">
             <a:avLst>
@@ -5374,7 +5374,7 @@
         <p:spPr>
           <a:xfrm>
             <a:off x="1078992" y="4946904"/>
-            <a:ext cx="4572000" cy="658368"/>
+            <a:ext cx="3633048" cy="658368"/>
           </a:xfrm>
           <a:prstGeom prst="rect">
             <a:avLst/>
@@ -5422,7 +5422,7 @@
         <p:spPr>
           <a:xfrm>
             <a:off x="1078992" y="5715000"/>
-            <a:ext cx="4572000" cy="274320"/>
+            <a:ext cx="3633048" cy="274320"/>
           </a:xfrm>
           <a:prstGeom prst="rect">
             <a:avLst/>
@@ -6107,7 +6107,7 @@
         <p:spPr>
           <a:xfrm>
             <a:off x="731520" y="256032"/>
-            <a:ext cx="10058400" cy="256032"/>
+            <a:ext cx="7436815" cy="256032"/>
           </a:xfrm>
           <a:prstGeom prst="rect">
             <a:avLst/>
@@ -6144,7 +6144,7 @@
         <p:spPr>
           <a:xfrm>
             <a:off x="731520" y="530352"/>
-            <a:ext cx="10058400" cy="457200"/>
+            <a:ext cx="7436815" cy="457200"/>
           </a:xfrm>
           <a:prstGeom prst="rect">
             <a:avLst/>
@@ -6181,7 +6181,7 @@
         <p:spPr>
           <a:xfrm>
             <a:off x="731520" y="1325880"/>
-            <a:ext cx="5029200" cy="1572768"/>
+            <a:ext cx="4090248" cy="1572768"/>
           </a:xfrm>
           <a:prstGeom prst="roundRect">
             <a:avLst>
@@ -6271,7 +6271,7 @@
         <p:spPr>
           <a:xfrm>
             <a:off x="1078992" y="1435608"/>
-            <a:ext cx="4572000" cy="658368"/>
+            <a:ext cx="3633048" cy="658368"/>
           </a:xfrm>
           <a:prstGeom prst="rect">
             <a:avLst/>
@@ -6319,7 +6319,7 @@
         <p:spPr>
           <a:xfrm>
             <a:off x="1078992" y="2203704"/>
-            <a:ext cx="4572000" cy="274320"/>
+            <a:ext cx="3633048" cy="274320"/>
           </a:xfrm>
           <a:prstGeom prst="rect">
             <a:avLst/>
@@ -6356,7 +6356,7 @@
         <p:spPr>
           <a:xfrm>
             <a:off x="731520" y="3081528"/>
-            <a:ext cx="5029200" cy="1572768"/>
+            <a:ext cx="4090248" cy="1572768"/>
           </a:xfrm>
           <a:prstGeom prst="roundRect">
             <a:avLst>
@@ -6446,7 +6446,7 @@
         <p:spPr>
           <a:xfrm>
             <a:off x="1078992" y="3191256"/>
-            <a:ext cx="4572000" cy="658368"/>
+            <a:ext cx="3633048" cy="658368"/>
           </a:xfrm>
           <a:prstGeom prst="rect">
             <a:avLst/>
@@ -6494,7 +6494,7 @@
         <p:spPr>
           <a:xfrm>
             <a:off x="1078992" y="3959352"/>
-            <a:ext cx="4572000" cy="274320"/>
+            <a:ext cx="3633048" cy="274320"/>
           </a:xfrm>
           <a:prstGeom prst="rect">
             <a:avLst/>
@@ -6531,7 +6531,7 @@
         <p:spPr>
           <a:xfrm>
             <a:off x="731520" y="4837176"/>
-            <a:ext cx="5029200" cy="1572768"/>
+            <a:ext cx="4090248" cy="1572768"/>
           </a:xfrm>
           <a:prstGeom prst="roundRect">
             <a:avLst>
@@ -6621,7 +6621,7 @@
         <p:spPr>
           <a:xfrm>
             <a:off x="1078992" y="4946904"/>
-            <a:ext cx="4572000" cy="658368"/>
+            <a:ext cx="3633048" cy="658368"/>
           </a:xfrm>
           <a:prstGeom prst="rect">
             <a:avLst/>
@@ -6669,7 +6669,7 @@
         <p:spPr>
           <a:xfrm>
             <a:off x="1078992" y="5715000"/>
-            <a:ext cx="4572000" cy="274320"/>
+            <a:ext cx="3633048" cy="274320"/>
           </a:xfrm>
           <a:prstGeom prst="rect">
             <a:avLst/>
@@ -7475,7 +7475,7 @@
         <p:spPr>
           <a:xfrm>
             <a:off x="731520" y="256032"/>
-            <a:ext cx="10058400" cy="256032"/>
+            <a:ext cx="7436815" cy="256032"/>
           </a:xfrm>
           <a:prstGeom prst="rect">
             <a:avLst/>
@@ -7512,7 +7512,7 @@
         <p:spPr>
           <a:xfrm>
             <a:off x="731520" y="530352"/>
-            <a:ext cx="10058400" cy="457200"/>
+            <a:ext cx="7436815" cy="457200"/>
           </a:xfrm>
           <a:prstGeom prst="rect">
             <a:avLst/>
@@ -7549,7 +7549,7 @@
         <p:spPr>
           <a:xfrm>
             <a:off x="731520" y="1325880"/>
-            <a:ext cx="5029200" cy="1572768"/>
+            <a:ext cx="4090248" cy="1572768"/>
           </a:xfrm>
           <a:prstGeom prst="roundRect">
             <a:avLst>
@@ -7639,7 +7639,7 @@
         <p:spPr>
           <a:xfrm>
             <a:off x="1078992" y="1435608"/>
-            <a:ext cx="4572000" cy="658368"/>
+            <a:ext cx="3633048" cy="658368"/>
           </a:xfrm>
           <a:prstGeom prst="rect">
             <a:avLst/>
@@ -7687,7 +7687,7 @@
         <p:spPr>
           <a:xfrm>
             <a:off x="1078992" y="2203704"/>
-            <a:ext cx="4572000" cy="274320"/>
+            <a:ext cx="3633048" cy="274320"/>
           </a:xfrm>
           <a:prstGeom prst="rect">
             <a:avLst/>
@@ -7724,7 +7724,7 @@
         <p:spPr>
           <a:xfrm>
             <a:off x="731520" y="3081528"/>
-            <a:ext cx="5029200" cy="1572768"/>
+            <a:ext cx="4090248" cy="1572768"/>
           </a:xfrm>
           <a:prstGeom prst="roundRect">
             <a:avLst>
@@ -7814,7 +7814,7 @@
         <p:spPr>
           <a:xfrm>
             <a:off x="1078992" y="3191256"/>
-            <a:ext cx="4572000" cy="658368"/>
+            <a:ext cx="3633048" cy="658368"/>
           </a:xfrm>
           <a:prstGeom prst="rect">
             <a:avLst/>
@@ -7862,7 +7862,7 @@
         <p:spPr>
           <a:xfrm>
             <a:off x="1078992" y="3959352"/>
-            <a:ext cx="4572000" cy="274320"/>
+            <a:ext cx="3633048" cy="274320"/>
           </a:xfrm>
           <a:prstGeom prst="rect">
             <a:avLst/>
@@ -7899,7 +7899,7 @@
         <p:spPr>
           <a:xfrm>
             <a:off x="731520" y="4837176"/>
-            <a:ext cx="5029200" cy="1572768"/>
+            <a:ext cx="4090248" cy="1572768"/>
           </a:xfrm>
           <a:prstGeom prst="roundRect">
             <a:avLst>
@@ -7989,7 +7989,7 @@
         <p:spPr>
           <a:xfrm>
             <a:off x="1078992" y="4946904"/>
-            <a:ext cx="4572000" cy="658368"/>
+            <a:ext cx="3633048" cy="658368"/>
           </a:xfrm>
           <a:prstGeom prst="rect">
             <a:avLst/>
@@ -8037,7 +8037,7 @@
         <p:spPr>
           <a:xfrm>
             <a:off x="1078992" y="5715000"/>
-            <a:ext cx="4572000" cy="274320"/>
+            <a:ext cx="3633048" cy="274320"/>
           </a:xfrm>
           <a:prstGeom prst="rect">
             <a:avLst/>
@@ -8821,7 +8821,7 @@
         <p:spPr>
           <a:xfrm>
             <a:off x="731520" y="256032"/>
-            <a:ext cx="10058400" cy="256032"/>
+            <a:ext cx="7436815" cy="256032"/>
           </a:xfrm>
           <a:prstGeom prst="rect">
             <a:avLst/>
@@ -8858,7 +8858,7 @@
         <p:spPr>
           <a:xfrm>
             <a:off x="731520" y="530352"/>
-            <a:ext cx="10058400" cy="457200"/>
+            <a:ext cx="7436815" cy="457200"/>
           </a:xfrm>
           <a:prstGeom prst="rect">
             <a:avLst/>
@@ -8895,7 +8895,7 @@
         <p:spPr>
           <a:xfrm>
             <a:off x="731520" y="1325880"/>
-            <a:ext cx="5029200" cy="1572768"/>
+            <a:ext cx="4090248" cy="1572768"/>
           </a:xfrm>
           <a:prstGeom prst="roundRect">
             <a:avLst>
@@ -8985,7 +8985,7 @@
         <p:spPr>
           <a:xfrm>
             <a:off x="1078992" y="1435608"/>
-            <a:ext cx="4572000" cy="658368"/>
+            <a:ext cx="3633048" cy="658368"/>
           </a:xfrm>
           <a:prstGeom prst="rect">
             <a:avLst/>
@@ -9033,7 +9033,7 @@
         <p:spPr>
           <a:xfrm>
             <a:off x="1078992" y="2203704"/>
-            <a:ext cx="4572000" cy="274320"/>
+            <a:ext cx="3633048" cy="274320"/>
           </a:xfrm>
           <a:prstGeom prst="rect">
             <a:avLst/>
@@ -9070,7 +9070,7 @@
         <p:spPr>
           <a:xfrm>
             <a:off x="731520" y="3081528"/>
-            <a:ext cx="5029200" cy="1572768"/>
+            <a:ext cx="4090248" cy="1572768"/>
           </a:xfrm>
           <a:prstGeom prst="roundRect">
             <a:avLst>
@@ -9160,7 +9160,7 @@
         <p:spPr>
           <a:xfrm>
             <a:off x="1078992" y="3191256"/>
-            <a:ext cx="4572000" cy="658368"/>
+            <a:ext cx="3633048" cy="658368"/>
           </a:xfrm>
           <a:prstGeom prst="rect">
             <a:avLst/>
@@ -9208,7 +9208,7 @@
         <p:spPr>
           <a:xfrm>
             <a:off x="1078992" y="3959352"/>
-            <a:ext cx="4572000" cy="274320"/>
+            <a:ext cx="3633048" cy="274320"/>
           </a:xfrm>
           <a:prstGeom prst="rect">
             <a:avLst/>
@@ -9245,7 +9245,7 @@
         <p:spPr>
           <a:xfrm>
             <a:off x="731520" y="4837176"/>
-            <a:ext cx="5029200" cy="1572768"/>
+            <a:ext cx="4090248" cy="1572768"/>
           </a:xfrm>
           <a:prstGeom prst="roundRect">
             <a:avLst>
@@ -9335,7 +9335,7 @@
         <p:spPr>
           <a:xfrm>
             <a:off x="1078992" y="4946904"/>
-            <a:ext cx="4572000" cy="658368"/>
+            <a:ext cx="3633048" cy="658368"/>
           </a:xfrm>
           <a:prstGeom prst="rect">
             <a:avLst/>
@@ -9383,7 +9383,7 @@
         <p:spPr>
           <a:xfrm>
             <a:off x="1078992" y="5715000"/>
-            <a:ext cx="4572000" cy="274320"/>
+            <a:ext cx="3633048" cy="274320"/>
           </a:xfrm>
           <a:prstGeom prst="rect">
             <a:avLst/>
@@ -10244,7 +10244,7 @@
         <p:spPr>
           <a:xfrm>
             <a:off x="731520" y="256032"/>
-            <a:ext cx="10058400" cy="256032"/>
+            <a:ext cx="7436815" cy="256032"/>
           </a:xfrm>
           <a:prstGeom prst="rect">
             <a:avLst/>
@@ -10281,7 +10281,7 @@
         <p:spPr>
           <a:xfrm>
             <a:off x="731520" y="530352"/>
-            <a:ext cx="10058400" cy="457200"/>
+            <a:ext cx="7436815" cy="457200"/>
           </a:xfrm>
           <a:prstGeom prst="rect">
             <a:avLst/>
@@ -10318,7 +10318,7 @@
         <p:spPr>
           <a:xfrm>
             <a:off x="731520" y="1325880"/>
-            <a:ext cx="5029200" cy="1572768"/>
+            <a:ext cx="4090248" cy="1572768"/>
           </a:xfrm>
           <a:prstGeom prst="roundRect">
             <a:avLst>
@@ -10408,7 +10408,7 @@
         <p:spPr>
           <a:xfrm>
             <a:off x="1078992" y="1435608"/>
-            <a:ext cx="4572000" cy="658368"/>
+            <a:ext cx="3633048" cy="658368"/>
           </a:xfrm>
           <a:prstGeom prst="rect">
             <a:avLst/>
@@ -10456,7 +10456,7 @@
         <p:spPr>
           <a:xfrm>
             <a:off x="1078992" y="2203704"/>
-            <a:ext cx="4572000" cy="274320"/>
+            <a:ext cx="3633048" cy="274320"/>
           </a:xfrm>
           <a:prstGeom prst="rect">
             <a:avLst/>
@@ -10493,7 +10493,7 @@
         <p:spPr>
           <a:xfrm>
             <a:off x="731520" y="3081528"/>
-            <a:ext cx="5029200" cy="1572768"/>
+            <a:ext cx="4090248" cy="1572768"/>
           </a:xfrm>
           <a:prstGeom prst="roundRect">
             <a:avLst>
@@ -10583,7 +10583,7 @@
         <p:spPr>
           <a:xfrm>
             <a:off x="1078992" y="3191256"/>
-            <a:ext cx="4572000" cy="658368"/>
+            <a:ext cx="3633048" cy="658368"/>
           </a:xfrm>
           <a:prstGeom prst="rect">
             <a:avLst/>
@@ -10631,7 +10631,7 @@
         <p:spPr>
           <a:xfrm>
             <a:off x="1078992" y="3959352"/>
-            <a:ext cx="4572000" cy="274320"/>
+            <a:ext cx="3633048" cy="274320"/>
           </a:xfrm>
           <a:prstGeom prst="rect">
             <a:avLst/>
@@ -10668,7 +10668,7 @@
         <p:spPr>
           <a:xfrm>
             <a:off x="731520" y="4837176"/>
-            <a:ext cx="5029200" cy="1572768"/>
+            <a:ext cx="4090248" cy="1572768"/>
           </a:xfrm>
           <a:prstGeom prst="roundRect">
             <a:avLst>
@@ -10758,7 +10758,7 @@
         <p:spPr>
           <a:xfrm>
             <a:off x="1078992" y="4946904"/>
-            <a:ext cx="4572000" cy="658368"/>
+            <a:ext cx="3633048" cy="658368"/>
           </a:xfrm>
           <a:prstGeom prst="rect">
             <a:avLst/>
@@ -10806,7 +10806,7 @@
         <p:spPr>
           <a:xfrm>
             <a:off x="1078992" y="5715000"/>
-            <a:ext cx="4572000" cy="274320"/>
+            <a:ext cx="3633048" cy="274320"/>
           </a:xfrm>
           <a:prstGeom prst="rect">
             <a:avLst/>
@@ -11345,7 +11345,7 @@
         <p:spPr>
           <a:xfrm>
             <a:off x="731520" y="256032"/>
-            <a:ext cx="10058400" cy="256032"/>
+            <a:ext cx="7436815" cy="256032"/>
           </a:xfrm>
           <a:prstGeom prst="rect">
             <a:avLst/>
@@ -11382,7 +11382,7 @@
         <p:spPr>
           <a:xfrm>
             <a:off x="731520" y="530352"/>
-            <a:ext cx="10058400" cy="457200"/>
+            <a:ext cx="7436815" cy="457200"/>
           </a:xfrm>
           <a:prstGeom prst="rect">
             <a:avLst/>
@@ -11475,7 +11475,7 @@
         <p:spPr>
           <a:xfrm>
             <a:off x="1965960" y="1069848"/>
-            <a:ext cx="8366760" cy="384048"/>
+            <a:ext cx="6202375" cy="384048"/>
           </a:xfrm>
           <a:prstGeom prst="rect">
             <a:avLst/>
@@ -11523,7 +11523,7 @@
         <p:spPr>
           <a:xfrm>
             <a:off x="1965960" y="1353312"/>
-            <a:ext cx="8366760" cy="228600"/>
+            <a:ext cx="6202375" cy="228600"/>
           </a:xfrm>
           <a:prstGeom prst="rect">
             <a:avLst/>
@@ -11616,7 +11616,7 @@
         <p:spPr>
           <a:xfrm>
             <a:off x="1965960" y="1847088"/>
-            <a:ext cx="8366760" cy="384048"/>
+            <a:ext cx="6202375" cy="384048"/>
           </a:xfrm>
           <a:prstGeom prst="rect">
             <a:avLst/>
@@ -11664,7 +11664,7 @@
         <p:spPr>
           <a:xfrm>
             <a:off x="1965960" y="2130552"/>
-            <a:ext cx="8366760" cy="228600"/>
+            <a:ext cx="6202375" cy="228600"/>
           </a:xfrm>
           <a:prstGeom prst="rect">
             <a:avLst/>
@@ -11757,7 +11757,7 @@
         <p:spPr>
           <a:xfrm>
             <a:off x="1965960" y="2624328"/>
-            <a:ext cx="8366760" cy="384048"/>
+            <a:ext cx="6202375" cy="384048"/>
           </a:xfrm>
           <a:prstGeom prst="rect">
             <a:avLst/>
@@ -11805,7 +11805,7 @@
         <p:spPr>
           <a:xfrm>
             <a:off x="1965960" y="2907792"/>
-            <a:ext cx="8366760" cy="228600"/>
+            <a:ext cx="6202375" cy="228600"/>
           </a:xfrm>
           <a:prstGeom prst="rect">
             <a:avLst/>
@@ -11898,7 +11898,7 @@
         <p:spPr>
           <a:xfrm>
             <a:off x="1965960" y="3401568"/>
-            <a:ext cx="8366760" cy="384048"/>
+            <a:ext cx="8823960" cy="384048"/>
           </a:xfrm>
           <a:prstGeom prst="rect">
             <a:avLst/>
@@ -11946,7 +11946,7 @@
         <p:spPr>
           <a:xfrm>
             <a:off x="1965960" y="3685032"/>
-            <a:ext cx="8366760" cy="228600"/>
+            <a:ext cx="8823960" cy="228600"/>
           </a:xfrm>
           <a:prstGeom prst="rect">
             <a:avLst/>
@@ -12039,7 +12039,7 @@
         <p:spPr>
           <a:xfrm>
             <a:off x="1965960" y="4178808"/>
-            <a:ext cx="8366760" cy="384048"/>
+            <a:ext cx="8823960" cy="384048"/>
           </a:xfrm>
           <a:prstGeom prst="rect">
             <a:avLst/>
@@ -12087,7 +12087,7 @@
         <p:spPr>
           <a:xfrm>
             <a:off x="1965960" y="4462272"/>
-            <a:ext cx="8366760" cy="228600"/>
+            <a:ext cx="8823960" cy="228600"/>
           </a:xfrm>
           <a:prstGeom prst="rect">
             <a:avLst/>
@@ -12180,7 +12180,7 @@
         <p:spPr>
           <a:xfrm>
             <a:off x="1965960" y="4956048"/>
-            <a:ext cx="8366760" cy="384048"/>
+            <a:ext cx="8823960" cy="384048"/>
           </a:xfrm>
           <a:prstGeom prst="rect">
             <a:avLst/>
@@ -12228,7 +12228,7 @@
         <p:spPr>
           <a:xfrm>
             <a:off x="1965960" y="5239512"/>
-            <a:ext cx="8366760" cy="228600"/>
+            <a:ext cx="8823960" cy="228600"/>
           </a:xfrm>
           <a:prstGeom prst="rect">
             <a:avLst/>
@@ -12391,7 +12391,7 @@
         <p:spPr>
           <a:xfrm>
             <a:off x="731520" y="256032"/>
-            <a:ext cx="10058400" cy="256032"/>
+            <a:ext cx="7436815" cy="256032"/>
           </a:xfrm>
           <a:prstGeom prst="rect">
             <a:avLst/>
@@ -12428,7 +12428,7 @@
         <p:spPr>
           <a:xfrm>
             <a:off x="731520" y="530352"/>
-            <a:ext cx="10058400" cy="457200"/>
+            <a:ext cx="7436815" cy="457200"/>
           </a:xfrm>
           <a:prstGeom prst="rect">
             <a:avLst/>
@@ -12465,7 +12465,7 @@
         <p:spPr>
           <a:xfrm>
             <a:off x="731520" y="1417320"/>
-            <a:ext cx="9601200" cy="2331720"/>
+            <a:ext cx="7436815" cy="2331720"/>
           </a:xfrm>
           <a:prstGeom prst="roundRect">
             <a:avLst>
@@ -12512,7 +12512,7 @@
         <p:spPr>
           <a:xfrm>
             <a:off x="932688" y="1563624"/>
-            <a:ext cx="9235440" cy="228600"/>
+            <a:ext cx="7071055" cy="228600"/>
           </a:xfrm>
           <a:prstGeom prst="rect">
             <a:avLst/>
@@ -12592,7 +12592,7 @@
         <p:spPr>
           <a:xfrm>
             <a:off x="1078992" y="1856232"/>
-            <a:ext cx="9098280" cy="274320"/>
+            <a:ext cx="6933895" cy="274320"/>
           </a:xfrm>
           <a:prstGeom prst="rect">
             <a:avLst/>
@@ -12672,7 +12672,7 @@
         <p:spPr>
           <a:xfrm>
             <a:off x="1078992" y="2167128"/>
-            <a:ext cx="9098280" cy="274320"/>
+            <a:ext cx="6933895" cy="274320"/>
           </a:xfrm>
           <a:prstGeom prst="rect">
             <a:avLst/>
@@ -12818,7 +12818,7 @@
         <p:spPr>
           <a:xfrm>
             <a:off x="1078992" y="2478024"/>
-            <a:ext cx="9098280" cy="274320"/>
+            <a:ext cx="6933895" cy="274320"/>
           </a:xfrm>
           <a:prstGeom prst="rect">
             <a:avLst/>
@@ -12964,7 +12964,7 @@
         <p:spPr>
           <a:xfrm>
             <a:off x="1078992" y="2788920"/>
-            <a:ext cx="9098280" cy="274320"/>
+            <a:ext cx="6933895" cy="274320"/>
           </a:xfrm>
           <a:prstGeom prst="rect">
             <a:avLst/>
@@ -13110,7 +13110,7 @@
         <p:spPr>
           <a:xfrm>
             <a:off x="1078992" y="3099816"/>
-            <a:ext cx="9098280" cy="274320"/>
+            <a:ext cx="6933895" cy="274320"/>
           </a:xfrm>
           <a:prstGeom prst="rect">
             <a:avLst/>
@@ -13213,7 +13213,7 @@
         <p:spPr>
           <a:xfrm>
             <a:off x="731520" y="4160520"/>
-            <a:ext cx="9601200" cy="1289304"/>
+            <a:ext cx="10058400" cy="1289304"/>
           </a:xfrm>
           <a:prstGeom prst="roundRect">
             <a:avLst>
@@ -13260,7 +13260,7 @@
         <p:spPr>
           <a:xfrm>
             <a:off x="932688" y="4306824"/>
-            <a:ext cx="9235440" cy="228600"/>
+            <a:ext cx="9692640" cy="228600"/>
           </a:xfrm>
           <a:prstGeom prst="rect">
             <a:avLst/>
@@ -13340,7 +13340,7 @@
         <p:spPr>
           <a:xfrm>
             <a:off x="1078992" y="4599432"/>
-            <a:ext cx="9098280" cy="274320"/>
+            <a:ext cx="9555480" cy="274320"/>
           </a:xfrm>
           <a:prstGeom prst="rect">
             <a:avLst/>

</xml_diff>

<commit_message>
fix(pptx): wider PiP margin, _you() helper for all blueprint text
- Increased PiP margin from 0.2" to 0.6" so text doesn't visually overlap
- Added _you() helper to replace "Learner" with "You" in all blueprint-sourced text
- Applied to opener, closing, and recap slide content from CSV outcomes
- Zero "learner" references in generated deck-source.json

Co-Authored-By: Claude Opus 4.6 (1M context) <noreply@anthropic.com>

Former-commit-id: 454f950c9cedcc5cb4c1a861d01ad2b9f720cfaf
Former-commit-id: 3c7f4ad30d8022553f44d0fa78ec859de5987f00
Former-commit-id: 610656e0cb0ca9f30910f3f381da18c1941ca087
</commit_message>
<xml_diff>
--- a/course/modules/M01/L001/M01-L001-deck.pptx
+++ b/course/modules/M01/L001/M01-L001-deck.pptx
@@ -3214,7 +3214,7 @@
         <p:spPr>
           <a:xfrm>
             <a:off x="731520" y="1600200"/>
-            <a:ext cx="7436815" cy="228600"/>
+            <a:ext cx="7071055" cy="228600"/>
           </a:xfrm>
           <a:prstGeom prst="rect">
             <a:avLst/>
@@ -3251,7 +3251,7 @@
         <p:spPr>
           <a:xfrm>
             <a:off x="731520" y="1993392"/>
-            <a:ext cx="7436815" cy="329184"/>
+            <a:ext cx="7071055" cy="329184"/>
           </a:xfrm>
           <a:prstGeom prst="rect">
             <a:avLst/>
@@ -3288,7 +3288,7 @@
         <p:spPr>
           <a:xfrm>
             <a:off x="731520" y="2542032"/>
-            <a:ext cx="7436815" cy="822960"/>
+            <a:ext cx="7071055" cy="822960"/>
           </a:xfrm>
           <a:prstGeom prst="rect">
             <a:avLst/>
@@ -3475,7 +3475,7 @@
                 <a:ea typeface="Sarabun"/>
                 <a:cs typeface="Sarabun"/>
               </a:rPr>
-              <a:t>Learner can greet people politely, thank others, apologize, and respond yes/no in a friendly first encounter.</a:t>
+              <a:t>You can greet people politely, thank others, apologize, and respond yes/no in a friendly first encounter.</a:t>
             </a:r>
           </a:p>
         </p:txBody>
@@ -3732,7 +3732,7 @@
         <p:spPr>
           <a:xfrm>
             <a:off x="731520" y="256032"/>
-            <a:ext cx="7436815" cy="256032"/>
+            <a:ext cx="7071055" cy="256032"/>
           </a:xfrm>
           <a:prstGeom prst="rect">
             <a:avLst/>
@@ -3769,7 +3769,7 @@
         <p:spPr>
           <a:xfrm>
             <a:off x="731520" y="530352"/>
-            <a:ext cx="7436815" cy="457200"/>
+            <a:ext cx="7071055" cy="457200"/>
           </a:xfrm>
           <a:prstGeom prst="rect">
             <a:avLst/>
@@ -3806,7 +3806,7 @@
         <p:spPr>
           <a:xfrm>
             <a:off x="731520" y="1600200"/>
-            <a:ext cx="7436815" cy="1289304"/>
+            <a:ext cx="7071055" cy="1289304"/>
           </a:xfrm>
           <a:prstGeom prst="roundRect">
             <a:avLst>
@@ -3853,7 +3853,7 @@
         <p:spPr>
           <a:xfrm>
             <a:off x="932688" y="1746504"/>
-            <a:ext cx="7071055" cy="228600"/>
+            <a:ext cx="6705295" cy="228600"/>
           </a:xfrm>
           <a:prstGeom prst="rect">
             <a:avLst/>
@@ -3933,7 +3933,7 @@
         <p:spPr>
           <a:xfrm>
             <a:off x="1078992" y="2039112"/>
-            <a:ext cx="6933895" cy="274320"/>
+            <a:ext cx="6568135" cy="274320"/>
           </a:xfrm>
           <a:prstGeom prst="rect">
             <a:avLst/>
@@ -4013,7 +4013,7 @@
         <p:spPr>
           <a:xfrm>
             <a:off x="1078992" y="2350008"/>
-            <a:ext cx="6933895" cy="274320"/>
+            <a:ext cx="6568135" cy="274320"/>
           </a:xfrm>
           <a:prstGeom prst="rect">
             <a:avLst/>
@@ -4176,7 +4176,7 @@
         <p:spPr>
           <a:xfrm>
             <a:off x="731520" y="256032"/>
-            <a:ext cx="7436815" cy="256032"/>
+            <a:ext cx="7071055" cy="256032"/>
           </a:xfrm>
           <a:prstGeom prst="rect">
             <a:avLst/>
@@ -4213,7 +4213,7 @@
         <p:spPr>
           <a:xfrm>
             <a:off x="731520" y="530352"/>
-            <a:ext cx="7436815" cy="457200"/>
+            <a:ext cx="7071055" cy="457200"/>
           </a:xfrm>
           <a:prstGeom prst="rect">
             <a:avLst/>
@@ -4860,7 +4860,7 @@
         <p:spPr>
           <a:xfrm>
             <a:off x="731520" y="256032"/>
-            <a:ext cx="7436815" cy="256032"/>
+            <a:ext cx="7071055" cy="256032"/>
           </a:xfrm>
           <a:prstGeom prst="rect">
             <a:avLst/>
@@ -4897,7 +4897,7 @@
         <p:spPr>
           <a:xfrm>
             <a:off x="731520" y="530352"/>
-            <a:ext cx="7436815" cy="457200"/>
+            <a:ext cx="7071055" cy="457200"/>
           </a:xfrm>
           <a:prstGeom prst="rect">
             <a:avLst/>
@@ -4934,7 +4934,7 @@
         <p:spPr>
           <a:xfrm>
             <a:off x="731520" y="1325880"/>
-            <a:ext cx="4090248" cy="1572768"/>
+            <a:ext cx="3889080" cy="1572768"/>
           </a:xfrm>
           <a:prstGeom prst="roundRect">
             <a:avLst>
@@ -5024,7 +5024,7 @@
         <p:spPr>
           <a:xfrm>
             <a:off x="1078992" y="1435608"/>
-            <a:ext cx="3633048" cy="658368"/>
+            <a:ext cx="3431880" cy="658368"/>
           </a:xfrm>
           <a:prstGeom prst="rect">
             <a:avLst/>
@@ -5072,7 +5072,7 @@
         <p:spPr>
           <a:xfrm>
             <a:off x="1078992" y="2203704"/>
-            <a:ext cx="3633048" cy="274320"/>
+            <a:ext cx="3431880" cy="274320"/>
           </a:xfrm>
           <a:prstGeom prst="rect">
             <a:avLst/>
@@ -5109,7 +5109,7 @@
         <p:spPr>
           <a:xfrm>
             <a:off x="731520" y="3081528"/>
-            <a:ext cx="4090248" cy="1572768"/>
+            <a:ext cx="3889080" cy="1572768"/>
           </a:xfrm>
           <a:prstGeom prst="roundRect">
             <a:avLst>
@@ -5199,7 +5199,7 @@
         <p:spPr>
           <a:xfrm>
             <a:off x="1078992" y="3191256"/>
-            <a:ext cx="3633048" cy="658368"/>
+            <a:ext cx="3431880" cy="658368"/>
           </a:xfrm>
           <a:prstGeom prst="rect">
             <a:avLst/>
@@ -5247,7 +5247,7 @@
         <p:spPr>
           <a:xfrm>
             <a:off x="1078992" y="3959352"/>
-            <a:ext cx="3633048" cy="274320"/>
+            <a:ext cx="3431880" cy="274320"/>
           </a:xfrm>
           <a:prstGeom prst="rect">
             <a:avLst/>
@@ -5284,7 +5284,7 @@
         <p:spPr>
           <a:xfrm>
             <a:off x="731520" y="4837176"/>
-            <a:ext cx="4090248" cy="1572768"/>
+            <a:ext cx="3889080" cy="1572768"/>
           </a:xfrm>
           <a:prstGeom prst="roundRect">
             <a:avLst>
@@ -5374,7 +5374,7 @@
         <p:spPr>
           <a:xfrm>
             <a:off x="1078992" y="4946904"/>
-            <a:ext cx="3633048" cy="658368"/>
+            <a:ext cx="3431880" cy="658368"/>
           </a:xfrm>
           <a:prstGeom prst="rect">
             <a:avLst/>
@@ -5422,7 +5422,7 @@
         <p:spPr>
           <a:xfrm>
             <a:off x="1078992" y="5715000"/>
-            <a:ext cx="3633048" cy="274320"/>
+            <a:ext cx="3431880" cy="274320"/>
           </a:xfrm>
           <a:prstGeom prst="rect">
             <a:avLst/>
@@ -6107,7 +6107,7 @@
         <p:spPr>
           <a:xfrm>
             <a:off x="731520" y="256032"/>
-            <a:ext cx="7436815" cy="256032"/>
+            <a:ext cx="7071055" cy="256032"/>
           </a:xfrm>
           <a:prstGeom prst="rect">
             <a:avLst/>
@@ -6144,7 +6144,7 @@
         <p:spPr>
           <a:xfrm>
             <a:off x="731520" y="530352"/>
-            <a:ext cx="7436815" cy="457200"/>
+            <a:ext cx="7071055" cy="457200"/>
           </a:xfrm>
           <a:prstGeom prst="rect">
             <a:avLst/>
@@ -6181,7 +6181,7 @@
         <p:spPr>
           <a:xfrm>
             <a:off x="731520" y="1325880"/>
-            <a:ext cx="4090248" cy="1572768"/>
+            <a:ext cx="3889080" cy="1572768"/>
           </a:xfrm>
           <a:prstGeom prst="roundRect">
             <a:avLst>
@@ -6271,7 +6271,7 @@
         <p:spPr>
           <a:xfrm>
             <a:off x="1078992" y="1435608"/>
-            <a:ext cx="3633048" cy="658368"/>
+            <a:ext cx="3431880" cy="658368"/>
           </a:xfrm>
           <a:prstGeom prst="rect">
             <a:avLst/>
@@ -6319,7 +6319,7 @@
         <p:spPr>
           <a:xfrm>
             <a:off x="1078992" y="2203704"/>
-            <a:ext cx="3633048" cy="274320"/>
+            <a:ext cx="3431880" cy="274320"/>
           </a:xfrm>
           <a:prstGeom prst="rect">
             <a:avLst/>
@@ -6356,7 +6356,7 @@
         <p:spPr>
           <a:xfrm>
             <a:off x="731520" y="3081528"/>
-            <a:ext cx="4090248" cy="1572768"/>
+            <a:ext cx="3889080" cy="1572768"/>
           </a:xfrm>
           <a:prstGeom prst="roundRect">
             <a:avLst>
@@ -6446,7 +6446,7 @@
         <p:spPr>
           <a:xfrm>
             <a:off x="1078992" y="3191256"/>
-            <a:ext cx="3633048" cy="658368"/>
+            <a:ext cx="3431880" cy="658368"/>
           </a:xfrm>
           <a:prstGeom prst="rect">
             <a:avLst/>
@@ -6494,7 +6494,7 @@
         <p:spPr>
           <a:xfrm>
             <a:off x="1078992" y="3959352"/>
-            <a:ext cx="3633048" cy="274320"/>
+            <a:ext cx="3431880" cy="274320"/>
           </a:xfrm>
           <a:prstGeom prst="rect">
             <a:avLst/>
@@ -6531,7 +6531,7 @@
         <p:spPr>
           <a:xfrm>
             <a:off x="731520" y="4837176"/>
-            <a:ext cx="4090248" cy="1572768"/>
+            <a:ext cx="3889080" cy="1572768"/>
           </a:xfrm>
           <a:prstGeom prst="roundRect">
             <a:avLst>
@@ -6621,7 +6621,7 @@
         <p:spPr>
           <a:xfrm>
             <a:off x="1078992" y="4946904"/>
-            <a:ext cx="3633048" cy="658368"/>
+            <a:ext cx="3431880" cy="658368"/>
           </a:xfrm>
           <a:prstGeom prst="rect">
             <a:avLst/>
@@ -6669,7 +6669,7 @@
         <p:spPr>
           <a:xfrm>
             <a:off x="1078992" y="5715000"/>
-            <a:ext cx="3633048" cy="274320"/>
+            <a:ext cx="3431880" cy="274320"/>
           </a:xfrm>
           <a:prstGeom prst="rect">
             <a:avLst/>
@@ -7475,7 +7475,7 @@
         <p:spPr>
           <a:xfrm>
             <a:off x="731520" y="256032"/>
-            <a:ext cx="7436815" cy="256032"/>
+            <a:ext cx="7071055" cy="256032"/>
           </a:xfrm>
           <a:prstGeom prst="rect">
             <a:avLst/>
@@ -7512,7 +7512,7 @@
         <p:spPr>
           <a:xfrm>
             <a:off x="731520" y="530352"/>
-            <a:ext cx="7436815" cy="457200"/>
+            <a:ext cx="7071055" cy="457200"/>
           </a:xfrm>
           <a:prstGeom prst="rect">
             <a:avLst/>
@@ -7549,7 +7549,7 @@
         <p:spPr>
           <a:xfrm>
             <a:off x="731520" y="1325880"/>
-            <a:ext cx="4090248" cy="1572768"/>
+            <a:ext cx="3889080" cy="1572768"/>
           </a:xfrm>
           <a:prstGeom prst="roundRect">
             <a:avLst>
@@ -7639,7 +7639,7 @@
         <p:spPr>
           <a:xfrm>
             <a:off x="1078992" y="1435608"/>
-            <a:ext cx="3633048" cy="658368"/>
+            <a:ext cx="3431880" cy="658368"/>
           </a:xfrm>
           <a:prstGeom prst="rect">
             <a:avLst/>
@@ -7687,7 +7687,7 @@
         <p:spPr>
           <a:xfrm>
             <a:off x="1078992" y="2203704"/>
-            <a:ext cx="3633048" cy="274320"/>
+            <a:ext cx="3431880" cy="274320"/>
           </a:xfrm>
           <a:prstGeom prst="rect">
             <a:avLst/>
@@ -7724,7 +7724,7 @@
         <p:spPr>
           <a:xfrm>
             <a:off x="731520" y="3081528"/>
-            <a:ext cx="4090248" cy="1572768"/>
+            <a:ext cx="3889080" cy="1572768"/>
           </a:xfrm>
           <a:prstGeom prst="roundRect">
             <a:avLst>
@@ -7814,7 +7814,7 @@
         <p:spPr>
           <a:xfrm>
             <a:off x="1078992" y="3191256"/>
-            <a:ext cx="3633048" cy="658368"/>
+            <a:ext cx="3431880" cy="658368"/>
           </a:xfrm>
           <a:prstGeom prst="rect">
             <a:avLst/>
@@ -7862,7 +7862,7 @@
         <p:spPr>
           <a:xfrm>
             <a:off x="1078992" y="3959352"/>
-            <a:ext cx="3633048" cy="274320"/>
+            <a:ext cx="3431880" cy="274320"/>
           </a:xfrm>
           <a:prstGeom prst="rect">
             <a:avLst/>
@@ -7899,7 +7899,7 @@
         <p:spPr>
           <a:xfrm>
             <a:off x="731520" y="4837176"/>
-            <a:ext cx="4090248" cy="1572768"/>
+            <a:ext cx="3889080" cy="1572768"/>
           </a:xfrm>
           <a:prstGeom prst="roundRect">
             <a:avLst>
@@ -7989,7 +7989,7 @@
         <p:spPr>
           <a:xfrm>
             <a:off x="1078992" y="4946904"/>
-            <a:ext cx="3633048" cy="658368"/>
+            <a:ext cx="3431880" cy="658368"/>
           </a:xfrm>
           <a:prstGeom prst="rect">
             <a:avLst/>
@@ -8037,7 +8037,7 @@
         <p:spPr>
           <a:xfrm>
             <a:off x="1078992" y="5715000"/>
-            <a:ext cx="3633048" cy="274320"/>
+            <a:ext cx="3431880" cy="274320"/>
           </a:xfrm>
           <a:prstGeom prst="rect">
             <a:avLst/>
@@ -8821,7 +8821,7 @@
         <p:spPr>
           <a:xfrm>
             <a:off x="731520" y="256032"/>
-            <a:ext cx="7436815" cy="256032"/>
+            <a:ext cx="7071055" cy="256032"/>
           </a:xfrm>
           <a:prstGeom prst="rect">
             <a:avLst/>
@@ -8858,7 +8858,7 @@
         <p:spPr>
           <a:xfrm>
             <a:off x="731520" y="530352"/>
-            <a:ext cx="7436815" cy="457200"/>
+            <a:ext cx="7071055" cy="457200"/>
           </a:xfrm>
           <a:prstGeom prst="rect">
             <a:avLst/>
@@ -8895,7 +8895,7 @@
         <p:spPr>
           <a:xfrm>
             <a:off x="731520" y="1325880"/>
-            <a:ext cx="4090248" cy="1572768"/>
+            <a:ext cx="3889080" cy="1572768"/>
           </a:xfrm>
           <a:prstGeom prst="roundRect">
             <a:avLst>
@@ -8985,7 +8985,7 @@
         <p:spPr>
           <a:xfrm>
             <a:off x="1078992" y="1435608"/>
-            <a:ext cx="3633048" cy="658368"/>
+            <a:ext cx="3431880" cy="658368"/>
           </a:xfrm>
           <a:prstGeom prst="rect">
             <a:avLst/>
@@ -9033,7 +9033,7 @@
         <p:spPr>
           <a:xfrm>
             <a:off x="1078992" y="2203704"/>
-            <a:ext cx="3633048" cy="274320"/>
+            <a:ext cx="3431880" cy="274320"/>
           </a:xfrm>
           <a:prstGeom prst="rect">
             <a:avLst/>
@@ -9070,7 +9070,7 @@
         <p:spPr>
           <a:xfrm>
             <a:off x="731520" y="3081528"/>
-            <a:ext cx="4090248" cy="1572768"/>
+            <a:ext cx="3889080" cy="1572768"/>
           </a:xfrm>
           <a:prstGeom prst="roundRect">
             <a:avLst>
@@ -9160,7 +9160,7 @@
         <p:spPr>
           <a:xfrm>
             <a:off x="1078992" y="3191256"/>
-            <a:ext cx="3633048" cy="658368"/>
+            <a:ext cx="3431880" cy="658368"/>
           </a:xfrm>
           <a:prstGeom prst="rect">
             <a:avLst/>
@@ -9208,7 +9208,7 @@
         <p:spPr>
           <a:xfrm>
             <a:off x="1078992" y="3959352"/>
-            <a:ext cx="3633048" cy="274320"/>
+            <a:ext cx="3431880" cy="274320"/>
           </a:xfrm>
           <a:prstGeom prst="rect">
             <a:avLst/>
@@ -9245,7 +9245,7 @@
         <p:spPr>
           <a:xfrm>
             <a:off x="731520" y="4837176"/>
-            <a:ext cx="4090248" cy="1572768"/>
+            <a:ext cx="3889080" cy="1572768"/>
           </a:xfrm>
           <a:prstGeom prst="roundRect">
             <a:avLst>
@@ -9335,7 +9335,7 @@
         <p:spPr>
           <a:xfrm>
             <a:off x="1078992" y="4946904"/>
-            <a:ext cx="3633048" cy="658368"/>
+            <a:ext cx="3431880" cy="658368"/>
           </a:xfrm>
           <a:prstGeom prst="rect">
             <a:avLst/>
@@ -9383,7 +9383,7 @@
         <p:spPr>
           <a:xfrm>
             <a:off x="1078992" y="5715000"/>
-            <a:ext cx="3633048" cy="274320"/>
+            <a:ext cx="3431880" cy="274320"/>
           </a:xfrm>
           <a:prstGeom prst="rect">
             <a:avLst/>
@@ -10244,7 +10244,7 @@
         <p:spPr>
           <a:xfrm>
             <a:off x="731520" y="256032"/>
-            <a:ext cx="7436815" cy="256032"/>
+            <a:ext cx="7071055" cy="256032"/>
           </a:xfrm>
           <a:prstGeom prst="rect">
             <a:avLst/>
@@ -10281,7 +10281,7 @@
         <p:spPr>
           <a:xfrm>
             <a:off x="731520" y="530352"/>
-            <a:ext cx="7436815" cy="457200"/>
+            <a:ext cx="7071055" cy="457200"/>
           </a:xfrm>
           <a:prstGeom prst="rect">
             <a:avLst/>
@@ -10318,7 +10318,7 @@
         <p:spPr>
           <a:xfrm>
             <a:off x="731520" y="1325880"/>
-            <a:ext cx="4090248" cy="1572768"/>
+            <a:ext cx="3889080" cy="1572768"/>
           </a:xfrm>
           <a:prstGeom prst="roundRect">
             <a:avLst>
@@ -10408,7 +10408,7 @@
         <p:spPr>
           <a:xfrm>
             <a:off x="1078992" y="1435608"/>
-            <a:ext cx="3633048" cy="658368"/>
+            <a:ext cx="3431880" cy="658368"/>
           </a:xfrm>
           <a:prstGeom prst="rect">
             <a:avLst/>
@@ -10456,7 +10456,7 @@
         <p:spPr>
           <a:xfrm>
             <a:off x="1078992" y="2203704"/>
-            <a:ext cx="3633048" cy="274320"/>
+            <a:ext cx="3431880" cy="274320"/>
           </a:xfrm>
           <a:prstGeom prst="rect">
             <a:avLst/>
@@ -10493,7 +10493,7 @@
         <p:spPr>
           <a:xfrm>
             <a:off x="731520" y="3081528"/>
-            <a:ext cx="4090248" cy="1572768"/>
+            <a:ext cx="3889080" cy="1572768"/>
           </a:xfrm>
           <a:prstGeom prst="roundRect">
             <a:avLst>
@@ -10583,7 +10583,7 @@
         <p:spPr>
           <a:xfrm>
             <a:off x="1078992" y="3191256"/>
-            <a:ext cx="3633048" cy="658368"/>
+            <a:ext cx="3431880" cy="658368"/>
           </a:xfrm>
           <a:prstGeom prst="rect">
             <a:avLst/>
@@ -10631,7 +10631,7 @@
         <p:spPr>
           <a:xfrm>
             <a:off x="1078992" y="3959352"/>
-            <a:ext cx="3633048" cy="274320"/>
+            <a:ext cx="3431880" cy="274320"/>
           </a:xfrm>
           <a:prstGeom prst="rect">
             <a:avLst/>
@@ -10668,7 +10668,7 @@
         <p:spPr>
           <a:xfrm>
             <a:off x="731520" y="4837176"/>
-            <a:ext cx="4090248" cy="1572768"/>
+            <a:ext cx="3889080" cy="1572768"/>
           </a:xfrm>
           <a:prstGeom prst="roundRect">
             <a:avLst>
@@ -10758,7 +10758,7 @@
         <p:spPr>
           <a:xfrm>
             <a:off x="1078992" y="4946904"/>
-            <a:ext cx="3633048" cy="658368"/>
+            <a:ext cx="3431880" cy="658368"/>
           </a:xfrm>
           <a:prstGeom prst="rect">
             <a:avLst/>
@@ -10806,7 +10806,7 @@
         <p:spPr>
           <a:xfrm>
             <a:off x="1078992" y="5715000"/>
-            <a:ext cx="3633048" cy="274320"/>
+            <a:ext cx="3431880" cy="274320"/>
           </a:xfrm>
           <a:prstGeom prst="rect">
             <a:avLst/>
@@ -11345,7 +11345,7 @@
         <p:spPr>
           <a:xfrm>
             <a:off x="731520" y="256032"/>
-            <a:ext cx="7436815" cy="256032"/>
+            <a:ext cx="7071055" cy="256032"/>
           </a:xfrm>
           <a:prstGeom prst="rect">
             <a:avLst/>
@@ -11382,7 +11382,7 @@
         <p:spPr>
           <a:xfrm>
             <a:off x="731520" y="530352"/>
-            <a:ext cx="7436815" cy="457200"/>
+            <a:ext cx="7071055" cy="457200"/>
           </a:xfrm>
           <a:prstGeom prst="rect">
             <a:avLst/>
@@ -11475,7 +11475,7 @@
         <p:spPr>
           <a:xfrm>
             <a:off x="1965960" y="1069848"/>
-            <a:ext cx="6202375" cy="384048"/>
+            <a:ext cx="5836615" cy="384048"/>
           </a:xfrm>
           <a:prstGeom prst="rect">
             <a:avLst/>
@@ -11523,7 +11523,7 @@
         <p:spPr>
           <a:xfrm>
             <a:off x="1965960" y="1353312"/>
-            <a:ext cx="6202375" cy="228600"/>
+            <a:ext cx="5836615" cy="228600"/>
           </a:xfrm>
           <a:prstGeom prst="rect">
             <a:avLst/>
@@ -11616,7 +11616,7 @@
         <p:spPr>
           <a:xfrm>
             <a:off x="1965960" y="1847088"/>
-            <a:ext cx="6202375" cy="384048"/>
+            <a:ext cx="5836615" cy="384048"/>
           </a:xfrm>
           <a:prstGeom prst="rect">
             <a:avLst/>
@@ -11664,7 +11664,7 @@
         <p:spPr>
           <a:xfrm>
             <a:off x="1965960" y="2130552"/>
-            <a:ext cx="6202375" cy="228600"/>
+            <a:ext cx="5836615" cy="228600"/>
           </a:xfrm>
           <a:prstGeom prst="rect">
             <a:avLst/>
@@ -11757,7 +11757,7 @@
         <p:spPr>
           <a:xfrm>
             <a:off x="1965960" y="2624328"/>
-            <a:ext cx="6202375" cy="384048"/>
+            <a:ext cx="5836615" cy="384048"/>
           </a:xfrm>
           <a:prstGeom prst="rect">
             <a:avLst/>
@@ -11805,7 +11805,7 @@
         <p:spPr>
           <a:xfrm>
             <a:off x="1965960" y="2907792"/>
-            <a:ext cx="6202375" cy="228600"/>
+            <a:ext cx="5836615" cy="228600"/>
           </a:xfrm>
           <a:prstGeom prst="rect">
             <a:avLst/>
@@ -12391,7 +12391,7 @@
         <p:spPr>
           <a:xfrm>
             <a:off x="731520" y="256032"/>
-            <a:ext cx="7436815" cy="256032"/>
+            <a:ext cx="7071055" cy="256032"/>
           </a:xfrm>
           <a:prstGeom prst="rect">
             <a:avLst/>
@@ -12428,7 +12428,7 @@
         <p:spPr>
           <a:xfrm>
             <a:off x="731520" y="530352"/>
-            <a:ext cx="7436815" cy="457200"/>
+            <a:ext cx="7071055" cy="457200"/>
           </a:xfrm>
           <a:prstGeom prst="rect">
             <a:avLst/>
@@ -12465,7 +12465,7 @@
         <p:spPr>
           <a:xfrm>
             <a:off x="731520" y="1417320"/>
-            <a:ext cx="7436815" cy="2331720"/>
+            <a:ext cx="7071055" cy="2331720"/>
           </a:xfrm>
           <a:prstGeom prst="roundRect">
             <a:avLst>
@@ -12512,7 +12512,7 @@
         <p:spPr>
           <a:xfrm>
             <a:off x="932688" y="1563624"/>
-            <a:ext cx="7071055" cy="228600"/>
+            <a:ext cx="6705295" cy="228600"/>
           </a:xfrm>
           <a:prstGeom prst="rect">
             <a:avLst/>
@@ -12592,7 +12592,7 @@
         <p:spPr>
           <a:xfrm>
             <a:off x="1078992" y="1856232"/>
-            <a:ext cx="6933895" cy="274320"/>
+            <a:ext cx="6568135" cy="274320"/>
           </a:xfrm>
           <a:prstGeom prst="rect">
             <a:avLst/>
@@ -12672,7 +12672,7 @@
         <p:spPr>
           <a:xfrm>
             <a:off x="1078992" y="2167128"/>
-            <a:ext cx="6933895" cy="274320"/>
+            <a:ext cx="6568135" cy="274320"/>
           </a:xfrm>
           <a:prstGeom prst="rect">
             <a:avLst/>
@@ -12818,7 +12818,7 @@
         <p:spPr>
           <a:xfrm>
             <a:off x="1078992" y="2478024"/>
-            <a:ext cx="6933895" cy="274320"/>
+            <a:ext cx="6568135" cy="274320"/>
           </a:xfrm>
           <a:prstGeom prst="rect">
             <a:avLst/>
@@ -12964,7 +12964,7 @@
         <p:spPr>
           <a:xfrm>
             <a:off x="1078992" y="2788920"/>
-            <a:ext cx="6933895" cy="274320"/>
+            <a:ext cx="6568135" cy="274320"/>
           </a:xfrm>
           <a:prstGeom prst="rect">
             <a:avLst/>
@@ -13110,7 +13110,7 @@
         <p:spPr>
           <a:xfrm>
             <a:off x="1078992" y="3099816"/>
-            <a:ext cx="6933895" cy="274320"/>
+            <a:ext cx="6568135" cy="274320"/>
           </a:xfrm>
           <a:prstGeom prst="rect">
             <a:avLst/>

</xml_diff>

<commit_message>
fix(pptx): objectives _you(), adaptive title font, prevent wrap overlap
- Apply _you() to objectives slide (was still showing "Learner can...")
- Section headers use 28pt for titles > 35 chars to prevent wrapping
- Increased header textbox height from 0.5" to 0.7" for 2-line titles

Co-Authored-By: Claude Opus 4.6 (1M context) <noreply@anthropic.com>

Former-commit-id: e619b93aaff0caada57261f3bbb5a0f10a88e1cc
Former-commit-id: 06e0ef1cc679147fa94074f942c44883872839ec
Former-commit-id: 4c96d30b9c959cc1c6675bc0817c1a9546f588a3
</commit_message>
<xml_diff>
--- a/course/modules/M01/L001/M01-L001-deck.pptx
+++ b/course/modules/M01/L001/M01-L001-deck.pptx
@@ -3769,7 +3769,7 @@
         <p:spPr>
           <a:xfrm>
             <a:off x="731520" y="530352"/>
-            <a:ext cx="7071055" cy="457200"/>
+            <a:ext cx="7071055" cy="640080"/>
           </a:xfrm>
           <a:prstGeom prst="rect">
             <a:avLst/>
@@ -4213,7 +4213,7 @@
         <p:spPr>
           <a:xfrm>
             <a:off x="731520" y="530352"/>
-            <a:ext cx="7071055" cy="457200"/>
+            <a:ext cx="7071055" cy="640080"/>
           </a:xfrm>
           <a:prstGeom prst="rect">
             <a:avLst/>
@@ -4357,7 +4357,7 @@
                 <a:ea typeface="Sarabun"/>
                 <a:cs typeface="Sarabun"/>
               </a:rPr>
-              <a:t>Learner can greet people politely, thank others, apologize, and respond yes/no in a friendly first encounter.</a:t>
+              <a:t>You can greet people politely, thank others, apologize, and respond yes/no in a friendly first encounter.</a:t>
             </a:r>
           </a:p>
         </p:txBody>
@@ -4478,7 +4478,7 @@
                 <a:ea typeface="Sarabun"/>
                 <a:cs typeface="Sarabun"/>
               </a:rPr>
-              <a:t>Learner can recycle recent vocabulary while using basic affirmation and negation in short controlled output.</a:t>
+              <a:t>You can recycle recent vocabulary while using basic affirmation and negation in short controlled output.</a:t>
             </a:r>
           </a:p>
         </p:txBody>
@@ -4897,7 +4897,7 @@
         <p:spPr>
           <a:xfrm>
             <a:off x="731520" y="530352"/>
-            <a:ext cx="7071055" cy="457200"/>
+            <a:ext cx="7071055" cy="640080"/>
           </a:xfrm>
           <a:prstGeom prst="rect">
             <a:avLst/>
@@ -6144,7 +6144,7 @@
         <p:spPr>
           <a:xfrm>
             <a:off x="731520" y="530352"/>
-            <a:ext cx="7071055" cy="457200"/>
+            <a:ext cx="7071055" cy="640080"/>
           </a:xfrm>
           <a:prstGeom prst="rect">
             <a:avLst/>
@@ -6159,7 +6159,7 @@
           <a:p>
             <a:pPr algn="l"/>
             <a:r>
-              <a:rPr sz="3600" b="1" i="0" lang="en-US" altLang="en-US">
+              <a:rPr sz="2800" b="1" i="0" lang="en-US" altLang="en-US">
                 <a:solidFill>
                   <a:srgbClr val="24333D"/>
                 </a:solidFill>
@@ -7512,7 +7512,7 @@
         <p:spPr>
           <a:xfrm>
             <a:off x="731520" y="530352"/>
-            <a:ext cx="7071055" cy="457200"/>
+            <a:ext cx="7071055" cy="640080"/>
           </a:xfrm>
           <a:prstGeom prst="rect">
             <a:avLst/>
@@ -8858,7 +8858,7 @@
         <p:spPr>
           <a:xfrm>
             <a:off x="731520" y="530352"/>
-            <a:ext cx="7071055" cy="457200"/>
+            <a:ext cx="7071055" cy="640080"/>
           </a:xfrm>
           <a:prstGeom prst="rect">
             <a:avLst/>
@@ -8873,7 +8873,7 @@
           <a:p>
             <a:pPr algn="l"/>
             <a:r>
-              <a:rPr sz="3600" b="1" i="0" lang="en-US" altLang="en-US">
+              <a:rPr sz="2800" b="1" i="0" lang="en-US" altLang="en-US">
                 <a:solidFill>
                   <a:srgbClr val="24333D"/>
                 </a:solidFill>
@@ -10281,7 +10281,7 @@
         <p:spPr>
           <a:xfrm>
             <a:off x="731520" y="530352"/>
-            <a:ext cx="7071055" cy="457200"/>
+            <a:ext cx="7071055" cy="640080"/>
           </a:xfrm>
           <a:prstGeom prst="rect">
             <a:avLst/>
@@ -10296,7 +10296,7 @@
           <a:p>
             <a:pPr algn="l"/>
             <a:r>
-              <a:rPr sz="3600" b="1" i="0" lang="en-US" altLang="en-US">
+              <a:rPr sz="2800" b="1" i="0" lang="en-US" altLang="en-US">
                 <a:solidFill>
                   <a:srgbClr val="24333D"/>
                 </a:solidFill>
@@ -11382,7 +11382,7 @@
         <p:spPr>
           <a:xfrm>
             <a:off x="731520" y="530352"/>
-            <a:ext cx="7071055" cy="457200"/>
+            <a:ext cx="7071055" cy="640080"/>
           </a:xfrm>
           <a:prstGeom prst="rect">
             <a:avLst/>
@@ -12428,7 +12428,7 @@
         <p:spPr>
           <a:xfrm>
             <a:off x="731520" y="530352"/>
-            <a:ext cx="7071055" cy="457200"/>
+            <a:ext cx="7071055" cy="640080"/>
           </a:xfrm>
           <a:prstGeom prst="rect">
             <a:avLst/>

</xml_diff>